<commit_message>
Autonomous Agent Optimization: 2026-04-23 10:48
</commit_message>
<xml_diff>
--- a/pipeline/snapshots/missions/m_1776946722_48ae32e0/implementation_plan.pptx
+++ b/pipeline/snapshots/missions/m_1776946722_48ae32e0/implementation_plan.pptx
@@ -3311,7 +3311,7 @@
                 </a:solidFill>
                 <a:latin typeface="Calibri"/>
               </a:rPr>
-              <a:t>Generated 2026-04-23T13:44:03 UTC</a:t>
+              <a:t>Generated 2026-04-23T14:47:59 UTC</a:t>
             </a:r>
           </a:p>
         </p:txBody>
@@ -5955,7 +5955,7 @@
                 </a:solidFill>
                 <a:latin typeface="Calibri"/>
               </a:rPr>
-              <a:t>Mission m_1776946722_48ae32e0  ·  refreshed 2026-04-23T13:44:03 UTC  ·  progress 0%</a:t>
+              <a:t>Mission m_1776946722_48ae32e0  ·  refreshed 2026-04-23T14:47:59 UTC  ·  progress 0%</a:t>
             </a:r>
           </a:p>
         </p:txBody>

</xml_diff>

<commit_message>
Autonomous Agent Optimization: 2026-04-23 11:52
</commit_message>
<xml_diff>
--- a/pipeline/snapshots/missions/m_1776946722_48ae32e0/implementation_plan.pptx
+++ b/pipeline/snapshots/missions/m_1776946722_48ae32e0/implementation_plan.pptx
@@ -3311,7 +3311,7 @@
                 </a:solidFill>
                 <a:latin typeface="Calibri"/>
               </a:rPr>
-              <a:t>Generated 2026-04-23T14:47:59 UTC</a:t>
+              <a:t>Generated 2026-04-23T15:51:56 UTC</a:t>
             </a:r>
           </a:p>
         </p:txBody>
@@ -5955,7 +5955,7 @@
                 </a:solidFill>
                 <a:latin typeface="Calibri"/>
               </a:rPr>
-              <a:t>Mission m_1776946722_48ae32e0  ·  refreshed 2026-04-23T14:47:59 UTC  ·  progress 0%</a:t>
+              <a:t>Mission m_1776946722_48ae32e0  ·  refreshed 2026-04-23T15:51:56 UTC  ·  progress 0%</a:t>
             </a:r>
           </a:p>
         </p:txBody>

</xml_diff>